<commit_message>
feat(artefacts): flip PDF + PPTX to Organic Modern palette
Re-palette the ReportLab client PDF and the python-pptx pitch deck so the
downloadable artefacts read as a continuation of the new ivory-page UI rather
than the former dark-SaaS aesthetic.

- justify.py: eyebrow #C9694E → #2F4A3F (forest), rules #A68A5B → #C9B79C
  (sand), body #181816 → #1C1F1A (ink), link colour #C9694E → #2F4A3F.
- justify_pptx.py: deck bg flipped from near-black INK to ivory canvas,
  default text from bone to ink, accent and rule colours rebound to forest
  and sand-deep. Same 6-slide 16:9 structure.
- Re-rendered the saved Lumen pitch deck (39 KB → still 39 KB, same structure,
  new identity); Justify + PPTX tests (10 total) stay green.
- BUILD_LOG.md iter 13-15 appended (P0 viewer overflow, cross-page chat,
  Organic Modern UI redesign).

Co-Authored-By: Claude Opus 4.7 (1M context) <noreply@anthropic.com>
</commit_message>
<xml_diff>
--- a/backend/tests/fixtures/lumen_justify_pitch_deck.pptx
+++ b/backend/tests/fixtures/lumen_justify_pitch_deck.pptx
@@ -3108,7 +3108,7 @@
             <a:avLst/>
           </a:prstGeom>
           <a:solidFill>
-            <a:srgbClr val="0E0E0C"/>
+            <a:srgbClr val="FAF7F2"/>
           </a:solidFill>
           <a:ln>
             <a:noFill/>
@@ -3161,7 +3161,7 @@
             <a:r>
               <a:rPr sz="1100" b="0" i="0">
                 <a:solidFill>
-                  <a:srgbClr val="C9694E"/>
+                  <a:srgbClr val="2F4A3F"/>
                 </a:solidFill>
                 <a:latin typeface="Courier New"/>
               </a:rPr>
@@ -3195,7 +3195,7 @@
             <a:r>
               <a:rPr sz="5600" b="1" i="0">
                 <a:solidFill>
-                  <a:srgbClr val="ECEBE4"/>
+                  <a:srgbClr val="1C1F1A"/>
                 </a:solidFill>
                 <a:latin typeface="Calibri"/>
               </a:rPr>
@@ -3221,7 +3221,7 @@
           </a:prstGeom>
           <a:ln w="12700">
             <a:solidFill>
-              <a:srgbClr val="A68A5B"/>
+              <a:srgbClr val="A08863"/>
             </a:solidFill>
           </a:ln>
         </p:spPr>
@@ -3265,7 +3265,7 @@
             <a:r>
               <a:rPr sz="2000" b="0" i="0">
                 <a:solidFill>
-                  <a:srgbClr val="ECEBE4"/>
+                  <a:srgbClr val="1C1F1A"/>
                 </a:solidFill>
                 <a:latin typeface="Calibri"/>
               </a:rPr>
@@ -3302,7 +3302,7 @@
             <a:r>
               <a:rPr sz="1000" b="0" i="0">
                 <a:solidFill>
-                  <a:srgbClr val="75716A"/>
+                  <a:srgbClr val="7F837D"/>
                 </a:solidFill>
                 <a:latin typeface="Courier New"/>
               </a:rPr>
@@ -3344,7 +3344,7 @@
             <a:avLst/>
           </a:prstGeom>
           <a:solidFill>
-            <a:srgbClr val="0E0E0C"/>
+            <a:srgbClr val="FAF7F2"/>
           </a:solidFill>
           <a:ln>
             <a:noFill/>
@@ -3397,7 +3397,7 @@
             <a:r>
               <a:rPr sz="1000" b="0" i="0">
                 <a:solidFill>
-                  <a:srgbClr val="C9694E"/>
+                  <a:srgbClr val="2F4A3F"/>
                 </a:solidFill>
                 <a:latin typeface="Courier New"/>
               </a:rPr>
@@ -3431,7 +3431,7 @@
             <a:r>
               <a:rPr sz="3600" b="1" i="0">
                 <a:solidFill>
-                  <a:srgbClr val="ECEBE4"/>
+                  <a:srgbClr val="1C1F1A"/>
                 </a:solidFill>
                 <a:latin typeface="Calibri"/>
               </a:rPr>
@@ -3456,7 +3456,7 @@
           </a:prstGeom>
           <a:ln w="12700">
             <a:solidFill>
-              <a:srgbClr val="A68A5B"/>
+              <a:srgbClr val="A08863"/>
             </a:solidFill>
           </a:ln>
         </p:spPr>
@@ -3500,7 +3500,7 @@
             <a:r>
               <a:rPr sz="1800" b="0" i="0">
                 <a:solidFill>
-                  <a:srgbClr val="ECEBE4"/>
+                  <a:srgbClr val="1C1F1A"/>
                 </a:solidFill>
                 <a:latin typeface="Calibri"/>
               </a:rPr>
@@ -3542,7 +3542,7 @@
             <a:avLst/>
           </a:prstGeom>
           <a:solidFill>
-            <a:srgbClr val="0E0E0C"/>
+            <a:srgbClr val="FAF7F2"/>
           </a:solidFill>
           <a:ln>
             <a:noFill/>
@@ -3595,7 +3595,7 @@
             <a:r>
               <a:rPr sz="1000" b="0" i="0">
                 <a:solidFill>
-                  <a:srgbClr val="C9694E"/>
+                  <a:srgbClr val="2F4A3F"/>
                 </a:solidFill>
                 <a:latin typeface="Courier New"/>
               </a:rPr>
@@ -3629,7 +3629,7 @@
             <a:r>
               <a:rPr sz="3600" b="1" i="0">
                 <a:solidFill>
-                  <a:srgbClr val="ECEBE4"/>
+                  <a:srgbClr val="1C1F1A"/>
                 </a:solidFill>
                 <a:latin typeface="Calibri"/>
               </a:rPr>
@@ -3654,7 +3654,7 @@
           </a:prstGeom>
           <a:ln w="12700">
             <a:solidFill>
-              <a:srgbClr val="A68A5B"/>
+              <a:srgbClr val="A08863"/>
             </a:solidFill>
           </a:ln>
         </p:spPr>
@@ -3690,11 +3690,11 @@
             </a:avLst>
           </a:prstGeom>
           <a:solidFill>
-            <a:srgbClr val="181816"/>
+            <a:srgbClr val="E8E3D8"/>
           </a:solidFill>
           <a:ln w="6350">
             <a:solidFill>
-              <a:srgbClr val="75716A"/>
+              <a:srgbClr val="7F837D"/>
             </a:solidFill>
           </a:ln>
         </p:spPr>
@@ -3745,7 +3745,7 @@
             <a:r>
               <a:rPr sz="1000" b="0" i="0">
                 <a:solidFill>
-                  <a:srgbClr val="A7A398"/>
+                  <a:srgbClr val="C6C1B4"/>
                 </a:solidFill>
                 <a:latin typeface="Courier New"/>
               </a:rPr>
@@ -3779,7 +3779,7 @@
             <a:r>
               <a:rPr sz="3800" b="1" i="0">
                 <a:solidFill>
-                  <a:srgbClr val="ECEBE4"/>
+                  <a:srgbClr val="1C1F1A"/>
                 </a:solidFill>
                 <a:latin typeface="Calibri"/>
               </a:rPr>
@@ -3805,11 +3805,11 @@
             </a:avLst>
           </a:prstGeom>
           <a:solidFill>
-            <a:srgbClr val="181816"/>
+            <a:srgbClr val="E8E3D8"/>
           </a:solidFill>
           <a:ln w="6350">
             <a:solidFill>
-              <a:srgbClr val="75716A"/>
+              <a:srgbClr val="7F837D"/>
             </a:solidFill>
           </a:ln>
         </p:spPr>
@@ -3860,7 +3860,7 @@
             <a:r>
               <a:rPr sz="1000" b="0" i="0">
                 <a:solidFill>
-                  <a:srgbClr val="A7A398"/>
+                  <a:srgbClr val="C6C1B4"/>
                 </a:solidFill>
                 <a:latin typeface="Courier New"/>
               </a:rPr>
@@ -3894,7 +3894,7 @@
             <a:r>
               <a:rPr sz="3800" b="1" i="0">
                 <a:solidFill>
-                  <a:srgbClr val="ECEBE4"/>
+                  <a:srgbClr val="1C1F1A"/>
                 </a:solidFill>
                 <a:latin typeface="Calibri"/>
               </a:rPr>
@@ -3920,11 +3920,11 @@
             </a:avLst>
           </a:prstGeom>
           <a:solidFill>
-            <a:srgbClr val="181816"/>
+            <a:srgbClr val="E8E3D8"/>
           </a:solidFill>
           <a:ln w="6350">
             <a:solidFill>
-              <a:srgbClr val="75716A"/>
+              <a:srgbClr val="7F837D"/>
             </a:solidFill>
           </a:ln>
         </p:spPr>
@@ -3975,7 +3975,7 @@
             <a:r>
               <a:rPr sz="1000" b="0" i="0">
                 <a:solidFill>
-                  <a:srgbClr val="A7A398"/>
+                  <a:srgbClr val="C6C1B4"/>
                 </a:solidFill>
                 <a:latin typeface="Courier New"/>
               </a:rPr>
@@ -4009,7 +4009,7 @@
             <a:r>
               <a:rPr sz="3800" b="1" i="0">
                 <a:solidFill>
-                  <a:srgbClr val="ECEBE4"/>
+                  <a:srgbClr val="1C1F1A"/>
                 </a:solidFill>
                 <a:latin typeface="Calibri"/>
               </a:rPr>
@@ -4035,11 +4035,11 @@
             </a:avLst>
           </a:prstGeom>
           <a:solidFill>
-            <a:srgbClr val="181816"/>
+            <a:srgbClr val="E8E3D8"/>
           </a:solidFill>
           <a:ln w="6350">
             <a:solidFill>
-              <a:srgbClr val="75716A"/>
+              <a:srgbClr val="7F837D"/>
             </a:solidFill>
           </a:ln>
         </p:spPr>
@@ -4090,7 +4090,7 @@
             <a:r>
               <a:rPr sz="1000" b="0" i="0">
                 <a:solidFill>
-                  <a:srgbClr val="A7A398"/>
+                  <a:srgbClr val="C6C1B4"/>
                 </a:solidFill>
                 <a:latin typeface="Courier New"/>
               </a:rPr>
@@ -4124,7 +4124,7 @@
             <a:r>
               <a:rPr sz="3800" b="1" i="0">
                 <a:solidFill>
-                  <a:srgbClr val="ECEBE4"/>
+                  <a:srgbClr val="1C1F1A"/>
                 </a:solidFill>
                 <a:latin typeface="Calibri"/>
               </a:rPr>
@@ -4150,11 +4150,11 @@
             </a:avLst>
           </a:prstGeom>
           <a:solidFill>
-            <a:srgbClr val="181816"/>
+            <a:srgbClr val="E8E3D8"/>
           </a:solidFill>
           <a:ln w="6350">
             <a:solidFill>
-              <a:srgbClr val="75716A"/>
+              <a:srgbClr val="7F837D"/>
             </a:solidFill>
           </a:ln>
         </p:spPr>
@@ -4205,7 +4205,7 @@
             <a:r>
               <a:rPr sz="1000" b="0" i="0">
                 <a:solidFill>
-                  <a:srgbClr val="A7A398"/>
+                  <a:srgbClr val="C6C1B4"/>
                 </a:solidFill>
                 <a:latin typeface="Courier New"/>
               </a:rPr>
@@ -4239,7 +4239,7 @@
             <a:r>
               <a:rPr sz="3800" b="1" i="0">
                 <a:solidFill>
-                  <a:srgbClr val="ECEBE4"/>
+                  <a:srgbClr val="1C1F1A"/>
                 </a:solidFill>
                 <a:latin typeface="Calibri"/>
               </a:rPr>
@@ -4265,11 +4265,11 @@
             </a:avLst>
           </a:prstGeom>
           <a:solidFill>
-            <a:srgbClr val="181816"/>
+            <a:srgbClr val="E8E3D8"/>
           </a:solidFill>
           <a:ln w="6350">
             <a:solidFill>
-              <a:srgbClr val="75716A"/>
+              <a:srgbClr val="7F837D"/>
             </a:solidFill>
           </a:ln>
         </p:spPr>
@@ -4320,7 +4320,7 @@
             <a:r>
               <a:rPr sz="1000" b="0" i="0">
                 <a:solidFill>
-                  <a:srgbClr val="A7A398"/>
+                  <a:srgbClr val="C6C1B4"/>
                 </a:solidFill>
                 <a:latin typeface="Courier New"/>
               </a:rPr>
@@ -4354,7 +4354,7 @@
             <a:r>
               <a:rPr sz="3800" b="1" i="0">
                 <a:solidFill>
-                  <a:srgbClr val="ECEBE4"/>
+                  <a:srgbClr val="1C1F1A"/>
                 </a:solidFill>
                 <a:latin typeface="Calibri"/>
               </a:rPr>
@@ -4396,7 +4396,7 @@
             <a:avLst/>
           </a:prstGeom>
           <a:solidFill>
-            <a:srgbClr val="0E0E0C"/>
+            <a:srgbClr val="FAF7F2"/>
           </a:solidFill>
           <a:ln>
             <a:noFill/>
@@ -4449,7 +4449,7 @@
             <a:r>
               <a:rPr sz="1000" b="0" i="0">
                 <a:solidFill>
-                  <a:srgbClr val="C9694E"/>
+                  <a:srgbClr val="2F4A3F"/>
                 </a:solidFill>
                 <a:latin typeface="Courier New"/>
               </a:rPr>
@@ -4483,7 +4483,7 @@
             <a:r>
               <a:rPr sz="3600" b="1" i="0">
                 <a:solidFill>
-                  <a:srgbClr val="ECEBE4"/>
+                  <a:srgbClr val="1C1F1A"/>
                 </a:solidFill>
                 <a:latin typeface="Calibri"/>
               </a:rPr>
@@ -4508,7 +4508,7 @@
           </a:prstGeom>
           <a:ln w="12700">
             <a:solidFill>
-              <a:srgbClr val="A68A5B"/>
+              <a:srgbClr val="A08863"/>
             </a:solidFill>
           </a:ln>
         </p:spPr>
@@ -4552,7 +4552,7 @@
             <a:r>
               <a:rPr sz="1500" b="0" i="0">
                 <a:solidFill>
-                  <a:srgbClr val="ECEBE4"/>
+                  <a:srgbClr val="1C1F1A"/>
                 </a:solidFill>
                 <a:latin typeface="Calibri"/>
               </a:rPr>
@@ -4593,7 +4593,7 @@
             <a:r>
               <a:rPr sz="900" b="0" i="0">
                 <a:solidFill>
-                  <a:srgbClr val="A7A398"/>
+                  <a:srgbClr val="C6C1B4"/>
                 </a:solidFill>
                 <a:latin typeface="Courier New"/>
               </a:rPr>
@@ -4635,7 +4635,7 @@
             <a:avLst/>
           </a:prstGeom>
           <a:solidFill>
-            <a:srgbClr val="0E0E0C"/>
+            <a:srgbClr val="FAF7F2"/>
           </a:solidFill>
           <a:ln>
             <a:noFill/>
@@ -4688,7 +4688,7 @@
             <a:r>
               <a:rPr sz="1000" b="0" i="0">
                 <a:solidFill>
-                  <a:srgbClr val="C9694E"/>
+                  <a:srgbClr val="2F4A3F"/>
                 </a:solidFill>
                 <a:latin typeface="Courier New"/>
               </a:rPr>
@@ -4722,7 +4722,7 @@
             <a:r>
               <a:rPr sz="3600" b="1" i="0">
                 <a:solidFill>
-                  <a:srgbClr val="ECEBE4"/>
+                  <a:srgbClr val="1C1F1A"/>
                 </a:solidFill>
                 <a:latin typeface="Calibri"/>
               </a:rPr>
@@ -4747,7 +4747,7 @@
           </a:prstGeom>
           <a:ln w="12700">
             <a:solidFill>
-              <a:srgbClr val="A68A5B"/>
+              <a:srgbClr val="A08863"/>
             </a:solidFill>
           </a:ln>
         </p:spPr>
@@ -4791,7 +4791,7 @@
             <a:r>
               <a:rPr sz="1500" b="0" i="0">
                 <a:solidFill>
-                  <a:srgbClr val="ECEBE4"/>
+                  <a:srgbClr val="1C1F1A"/>
                 </a:solidFill>
                 <a:latin typeface="Calibri"/>
               </a:rPr>
@@ -4838,7 +4838,7 @@
             <a:r>
               <a:rPr sz="900" b="0" i="0">
                 <a:solidFill>
-                  <a:srgbClr val="A7A398"/>
+                  <a:srgbClr val="C6C1B4"/>
                 </a:solidFill>
                 <a:latin typeface="Courier New"/>
               </a:rPr>
@@ -4880,7 +4880,7 @@
             <a:avLst/>
           </a:prstGeom>
           <a:solidFill>
-            <a:srgbClr val="0E0E0C"/>
+            <a:srgbClr val="FAF7F2"/>
           </a:solidFill>
           <a:ln>
             <a:noFill/>
@@ -4933,7 +4933,7 @@
             <a:r>
               <a:rPr sz="1000" b="0" i="0">
                 <a:solidFill>
-                  <a:srgbClr val="C9694E"/>
+                  <a:srgbClr val="2F4A3F"/>
                 </a:solidFill>
                 <a:latin typeface="Courier New"/>
               </a:rPr>
@@ -4967,7 +4967,7 @@
             <a:r>
               <a:rPr sz="3600" b="1" i="0">
                 <a:solidFill>
-                  <a:srgbClr val="ECEBE4"/>
+                  <a:srgbClr val="1C1F1A"/>
                 </a:solidFill>
                 <a:latin typeface="Calibri"/>
               </a:rPr>
@@ -4992,7 +4992,7 @@
           </a:prstGeom>
           <a:ln w="12700">
             <a:solidFill>
-              <a:srgbClr val="A68A5B"/>
+              <a:srgbClr val="A08863"/>
             </a:solidFill>
           </a:ln>
         </p:spPr>
@@ -5036,7 +5036,7 @@
             <a:r>
               <a:rPr sz="1000" b="0" i="0">
                 <a:solidFill>
-                  <a:srgbClr val="A68A5B"/>
+                  <a:srgbClr val="A08863"/>
                 </a:solidFill>
                 <a:latin typeface="Courier New"/>
               </a:rPr>
@@ -5070,7 +5070,7 @@
             <a:r>
               <a:rPr sz="1400" b="0" i="0">
                 <a:solidFill>
-                  <a:srgbClr val="ECEBE4"/>
+                  <a:srgbClr val="1C1F1A"/>
                 </a:solidFill>
                 <a:latin typeface="Calibri"/>
               </a:rPr>
@@ -5108,7 +5108,7 @@
             <a:r>
               <a:rPr sz="1000" b="0" i="0">
                 <a:solidFill>
-                  <a:srgbClr val="A68A5B"/>
+                  <a:srgbClr val="A08863"/>
                 </a:solidFill>
                 <a:latin typeface="Courier New"/>
               </a:rPr>
@@ -5142,7 +5142,7 @@
             <a:r>
               <a:rPr sz="1400" b="0" i="0">
                 <a:solidFill>
-                  <a:srgbClr val="ECEBE4"/>
+                  <a:srgbClr val="1C1F1A"/>
                 </a:solidFill>
                 <a:latin typeface="Calibri"/>
               </a:rPr>
@@ -5180,7 +5180,7 @@
             <a:r>
               <a:rPr sz="900" b="0" i="0">
                 <a:solidFill>
-                  <a:srgbClr val="A7A398"/>
+                  <a:srgbClr val="C6C1B4"/>
                 </a:solidFill>
                 <a:latin typeface="Courier New"/>
               </a:rPr>

</xml_diff>